<commit_message>
리뷰 반영 2차: fail-closed altText 가드·아이콘 정합·content_glow 제거
AI 리뷰(Opus 5 체어) MINOR 반영:
- verify-deck.sh altText pre-flight를 fail-closed로 — grep 실패/글롭 미매치가
  침묵 통과되지 않도록 addImage 라인 존재를 명시 단언 + 위반 라인 출력
- verify-deck.sh 헤더에 게이트 3 pre-flight 불변식 2종(집합 일치 핀 ·
  비어있지 않은 altText) 문서화 — 헤더/본문 완전성 일치
- 자산 핀을 전체 파일 기준 집합 일치로 확대(-type f, 확장자/깊이 무관)
- AI 레이어 슬라이드 아이콘 정합: aws-data(BFF-로컬)에 gateway 아이콘,
  콜렉터 6종에 memory 아이콘은 카드 본문과 모순 → aws_cloud/evaluations로 교체
- content_glow.png 제거(덱 미임베드 킷 예비 — 게이트 3 파리티가 못 보는
  단일 통제 자산이라 벤더링 트림에서 제외) → 핀 12종, README 계정 갱신
- applyBg 단순화(glow 모드 제거로 mode 파라미터 불용)

두 MAJOR(자산 미포함·pptx 미재생성)는 리뷰 diff의 바이너리 절단에 따른
오인 — head CI에서 Deck Verify(집합 일치 핀 + byte 파리티) green으로 반증됨.

Co-Authored-By: Claude Fable 5 <noreply@anthropic.com>
Claude-Session: https://claude.ai/code/session_01WUW3zRA2UNR7wAp6eczEiy
</commit_message>
<xml_diff>
--- a/docs-site/static/presentation/awsops-intro/awsops-intro.pptx
+++ b/docs-site/static/presentation/awsops-intro/awsops-intro.pptx
@@ -7578,7 +7578,7 @@
       </p:sp>
       <p:pic>
         <p:nvPicPr>
-          <p:cNvPr id="30" name="Image 1" descr="gateway icon">    </p:cNvPr>
+          <p:cNvPr id="30" name="Image 1" descr="aws_cloud icon">    </p:cNvPr>
           <p:cNvPicPr>
             <a:picLocks noChangeAspect="1"/>
           </p:cNvPicPr>
@@ -7737,7 +7737,7 @@
       </p:sp>
       <p:pic>
         <p:nvPicPr>
-          <p:cNvPr id="35" name="Image 2" descr="memory icon">    </p:cNvPr>
+          <p:cNvPr id="35" name="Image 2" descr="evaluations icon">    </p:cNvPr>
           <p:cNvPicPr>
             <a:picLocks noChangeAspect="1"/>
           </p:cNvPicPr>

</xml_diff>